<commit_message>
更新 PPTX 簡報 + 新增 nlm-chapters 圖片與藍圖 PPTX
</commit_message>
<xml_diff>
--- a/png/agentic-coding-slides.pptx
+++ b/png/agentic-coding-slides.pptx
@@ -5,20 +5,19 @@
     <p:sldMasterId id="2147483648" r:id="rId1"/>
   </p:sldMasterIdLst>
   <p:sldIdLst>
-    <p:sldId id="256" r:id="rId7"/>
-    <p:sldId id="257" r:id="rId8"/>
-    <p:sldId id="258" r:id="rId9"/>
-    <p:sldId id="259" r:id="rId10"/>
-    <p:sldId id="260" r:id="rId11"/>
-    <p:sldId id="261" r:id="rId12"/>
-    <p:sldId id="262" r:id="rId13"/>
-    <p:sldId id="263" r:id="rId14"/>
-    <p:sldId id="264" r:id="rId15"/>
-    <p:sldId id="265" r:id="rId16"/>
-    <p:sldId id="266" r:id="rId17"/>
-    <p:sldId id="267" r:id="rId18"/>
+    <p:sldId id="256" r:id="rId2"/>
+    <p:sldId id="257" r:id="rId3"/>
+    <p:sldId id="258" r:id="rId4"/>
+    <p:sldId id="259" r:id="rId5"/>
+    <p:sldId id="260" r:id="rId6"/>
+    <p:sldId id="261" r:id="rId7"/>
+    <p:sldId id="262" r:id="rId8"/>
+    <p:sldId id="263" r:id="rId9"/>
+    <p:sldId id="264" r:id="rId10"/>
+    <p:sldId id="265" r:id="rId11"/>
+    <p:sldId id="266" r:id="rId12"/>
   </p:sldIdLst>
-  <p:sldSz cx="12188952" cy="6858000" type="screen4x3"/>
+  <p:sldSz cx="12188825" cy="6858000"/>
   <p:notesSz cx="6858000" cy="9144000"/>
   <p:defaultTextStyle>
     <a:defPPr>
@@ -115,6 +114,22 @@
       </a:defRPr>
     </a:lvl9pPr>
   </p:defaultTextStyle>
+  <p:extLst>
+    <p:ext uri="{EFAFB233-063F-42B5-8137-9DF3F51BA10A}">
+      <p15:sldGuideLst xmlns:p15="http://schemas.microsoft.com/office/powerpoint/2012/main">
+        <p15:guide id="1" orient="horz" pos="2160">
+          <p15:clr>
+            <a:srgbClr val="A4A3A4"/>
+          </p15:clr>
+        </p15:guide>
+        <p15:guide id="2" pos="2880">
+          <p15:clr>
+            <a:srgbClr val="A4A3A4"/>
+          </p15:clr>
+        </p15:guide>
+      </p15:sldGuideLst>
+    </p:ext>
+  </p:extLst>
 </p:presentation>
 </file>
 
@@ -156,10 +171,9 @@
           <a:lstStyle/>
           <a:p>
             <a:r>
-              <a:rPr lang="en-US" smtClean="0"/>
+              <a:rPr lang="en-US"/>
               <a:t>Click to edit Master title style</a:t>
             </a:r>
-            <a:endParaRPr lang="en-US"/>
           </a:p>
         </p:txBody>
       </p:sp>
@@ -275,10 +289,9 @@
           </a:lstStyle>
           <a:p>
             <a:r>
-              <a:rPr lang="en-US" smtClean="0"/>
+              <a:rPr lang="en-US"/>
               <a:t>Click to edit Master subtitle style</a:t>
             </a:r>
-            <a:endParaRPr lang="en-US"/>
           </a:p>
         </p:txBody>
       </p:sp>
@@ -299,7 +312,7 @@
           <a:p>
             <a:fld id="{5BCAD085-E8A6-8845-BD4E-CB4CCA059FC4}" type="datetimeFigureOut">
               <a:rPr lang="en-US" smtClean="0"/>
-              <a:t>1/27/13</a:t>
+              <a:t>5/26/2026</a:t>
             </a:fld>
             <a:endParaRPr lang="en-US"/>
           </a:p>
@@ -393,10 +406,9 @@
           <a:lstStyle/>
           <a:p>
             <a:r>
-              <a:rPr lang="en-US" smtClean="0"/>
+              <a:rPr lang="en-US"/>
               <a:t>Click to edit Master title style</a:t>
             </a:r>
-            <a:endParaRPr lang="en-US"/>
           </a:p>
         </p:txBody>
       </p:sp>
@@ -417,38 +429,37 @@
           <a:p>
             <a:pPr lvl="0"/>
             <a:r>
-              <a:rPr lang="en-US" smtClean="0"/>
+              <a:rPr lang="en-US"/>
               <a:t>Click to edit Master text styles</a:t>
             </a:r>
           </a:p>
           <a:p>
             <a:pPr lvl="1"/>
             <a:r>
-              <a:rPr lang="en-US" smtClean="0"/>
+              <a:rPr lang="en-US"/>
               <a:t>Second level</a:t>
             </a:r>
           </a:p>
           <a:p>
             <a:pPr lvl="2"/>
             <a:r>
-              <a:rPr lang="en-US" smtClean="0"/>
+              <a:rPr lang="en-US"/>
               <a:t>Third level</a:t>
             </a:r>
           </a:p>
           <a:p>
             <a:pPr lvl="3"/>
             <a:r>
-              <a:rPr lang="en-US" smtClean="0"/>
+              <a:rPr lang="en-US"/>
               <a:t>Fourth level</a:t>
             </a:r>
           </a:p>
           <a:p>
             <a:pPr lvl="4"/>
             <a:r>
-              <a:rPr lang="en-US" smtClean="0"/>
+              <a:rPr lang="en-US"/>
               <a:t>Fifth level</a:t>
             </a:r>
-            <a:endParaRPr lang="en-US"/>
           </a:p>
         </p:txBody>
       </p:sp>
@@ -469,7 +480,7 @@
           <a:p>
             <a:fld id="{5BCAD085-E8A6-8845-BD4E-CB4CCA059FC4}" type="datetimeFigureOut">
               <a:rPr lang="en-US" smtClean="0"/>
-              <a:t>1/27/13</a:t>
+              <a:t>5/26/2026</a:t>
             </a:fld>
             <a:endParaRPr lang="en-US"/>
           </a:p>
@@ -568,10 +579,9 @@
           <a:lstStyle/>
           <a:p>
             <a:r>
-              <a:rPr lang="en-US" smtClean="0"/>
+              <a:rPr lang="en-US"/>
               <a:t>Click to edit Master title style</a:t>
             </a:r>
-            <a:endParaRPr lang="en-US"/>
           </a:p>
         </p:txBody>
       </p:sp>
@@ -597,38 +607,37 @@
           <a:p>
             <a:pPr lvl="0"/>
             <a:r>
-              <a:rPr lang="en-US" smtClean="0"/>
+              <a:rPr lang="en-US"/>
               <a:t>Click to edit Master text styles</a:t>
             </a:r>
           </a:p>
           <a:p>
             <a:pPr lvl="1"/>
             <a:r>
-              <a:rPr lang="en-US" smtClean="0"/>
+              <a:rPr lang="en-US"/>
               <a:t>Second level</a:t>
             </a:r>
           </a:p>
           <a:p>
             <a:pPr lvl="2"/>
             <a:r>
-              <a:rPr lang="en-US" smtClean="0"/>
+              <a:rPr lang="en-US"/>
               <a:t>Third level</a:t>
             </a:r>
           </a:p>
           <a:p>
             <a:pPr lvl="3"/>
             <a:r>
-              <a:rPr lang="en-US" smtClean="0"/>
+              <a:rPr lang="en-US"/>
               <a:t>Fourth level</a:t>
             </a:r>
           </a:p>
           <a:p>
             <a:pPr lvl="4"/>
             <a:r>
-              <a:rPr lang="en-US" smtClean="0"/>
+              <a:rPr lang="en-US"/>
               <a:t>Fifth level</a:t>
             </a:r>
-            <a:endParaRPr lang="en-US"/>
           </a:p>
         </p:txBody>
       </p:sp>
@@ -649,7 +658,7 @@
           <a:p>
             <a:fld id="{5BCAD085-E8A6-8845-BD4E-CB4CCA059FC4}" type="datetimeFigureOut">
               <a:rPr lang="en-US" smtClean="0"/>
-              <a:t>1/27/13</a:t>
+              <a:t>5/26/2026</a:t>
             </a:fld>
             <a:endParaRPr lang="en-US"/>
           </a:p>
@@ -743,10 +752,9 @@
           <a:lstStyle/>
           <a:p>
             <a:r>
-              <a:rPr lang="en-US" smtClean="0"/>
+              <a:rPr lang="en-US"/>
               <a:t>Click to edit Master title style</a:t>
             </a:r>
-            <a:endParaRPr lang="en-US"/>
           </a:p>
         </p:txBody>
       </p:sp>
@@ -767,38 +775,37 @@
           <a:p>
             <a:pPr lvl="0"/>
             <a:r>
-              <a:rPr lang="en-US" smtClean="0"/>
+              <a:rPr lang="en-US"/>
               <a:t>Click to edit Master text styles</a:t>
             </a:r>
           </a:p>
           <a:p>
             <a:pPr lvl="1"/>
             <a:r>
-              <a:rPr lang="en-US" smtClean="0"/>
+              <a:rPr lang="en-US"/>
               <a:t>Second level</a:t>
             </a:r>
           </a:p>
           <a:p>
             <a:pPr lvl="2"/>
             <a:r>
-              <a:rPr lang="en-US" smtClean="0"/>
+              <a:rPr lang="en-US"/>
               <a:t>Third level</a:t>
             </a:r>
           </a:p>
           <a:p>
             <a:pPr lvl="3"/>
             <a:r>
-              <a:rPr lang="en-US" smtClean="0"/>
+              <a:rPr lang="en-US"/>
               <a:t>Fourth level</a:t>
             </a:r>
           </a:p>
           <a:p>
             <a:pPr lvl="4"/>
             <a:r>
-              <a:rPr lang="en-US" smtClean="0"/>
+              <a:rPr lang="en-US"/>
               <a:t>Fifth level</a:t>
             </a:r>
-            <a:endParaRPr lang="en-US"/>
           </a:p>
         </p:txBody>
       </p:sp>
@@ -819,7 +826,7 @@
           <a:p>
             <a:fld id="{5BCAD085-E8A6-8845-BD4E-CB4CCA059FC4}" type="datetimeFigureOut">
               <a:rPr lang="en-US" smtClean="0"/>
-              <a:t>1/27/13</a:t>
+              <a:t>5/26/2026</a:t>
             </a:fld>
             <a:endParaRPr lang="en-US"/>
           </a:p>
@@ -922,10 +929,9 @@
           </a:lstStyle>
           <a:p>
             <a:r>
-              <a:rPr lang="en-US" smtClean="0"/>
+              <a:rPr lang="en-US"/>
               <a:t>Click to edit Master title style</a:t>
             </a:r>
-            <a:endParaRPr lang="en-US"/>
           </a:p>
         </p:txBody>
       </p:sp>
@@ -1042,7 +1048,7 @@
           <a:p>
             <a:pPr lvl="0"/>
             <a:r>
-              <a:rPr lang="en-US" smtClean="0"/>
+              <a:rPr lang="en-US"/>
               <a:t>Click to edit Master text styles</a:t>
             </a:r>
           </a:p>
@@ -1065,7 +1071,7 @@
           <a:p>
             <a:fld id="{5BCAD085-E8A6-8845-BD4E-CB4CCA059FC4}" type="datetimeFigureOut">
               <a:rPr lang="en-US" smtClean="0"/>
-              <a:t>1/27/13</a:t>
+              <a:t>5/26/2026</a:t>
             </a:fld>
             <a:endParaRPr lang="en-US"/>
           </a:p>
@@ -1159,10 +1165,9 @@
           <a:lstStyle/>
           <a:p>
             <a:r>
-              <a:rPr lang="en-US" smtClean="0"/>
+              <a:rPr lang="en-US"/>
               <a:t>Click to edit Master title style</a:t>
             </a:r>
-            <a:endParaRPr lang="en-US"/>
           </a:p>
         </p:txBody>
       </p:sp>
@@ -1216,38 +1221,37 @@
           <a:p>
             <a:pPr lvl="0"/>
             <a:r>
-              <a:rPr lang="en-US" smtClean="0"/>
+              <a:rPr lang="en-US"/>
               <a:t>Click to edit Master text styles</a:t>
             </a:r>
           </a:p>
           <a:p>
             <a:pPr lvl="1"/>
             <a:r>
-              <a:rPr lang="en-US" smtClean="0"/>
+              <a:rPr lang="en-US"/>
               <a:t>Second level</a:t>
             </a:r>
           </a:p>
           <a:p>
             <a:pPr lvl="2"/>
             <a:r>
-              <a:rPr lang="en-US" smtClean="0"/>
+              <a:rPr lang="en-US"/>
               <a:t>Third level</a:t>
             </a:r>
           </a:p>
           <a:p>
             <a:pPr lvl="3"/>
             <a:r>
-              <a:rPr lang="en-US" smtClean="0"/>
+              <a:rPr lang="en-US"/>
               <a:t>Fourth level</a:t>
             </a:r>
           </a:p>
           <a:p>
             <a:pPr lvl="4"/>
             <a:r>
-              <a:rPr lang="en-US" smtClean="0"/>
+              <a:rPr lang="en-US"/>
               <a:t>Fifth level</a:t>
             </a:r>
-            <a:endParaRPr lang="en-US"/>
           </a:p>
         </p:txBody>
       </p:sp>
@@ -1301,38 +1305,37 @@
           <a:p>
             <a:pPr lvl="0"/>
             <a:r>
-              <a:rPr lang="en-US" smtClean="0"/>
+              <a:rPr lang="en-US"/>
               <a:t>Click to edit Master text styles</a:t>
             </a:r>
           </a:p>
           <a:p>
             <a:pPr lvl="1"/>
             <a:r>
-              <a:rPr lang="en-US" smtClean="0"/>
+              <a:rPr lang="en-US"/>
               <a:t>Second level</a:t>
             </a:r>
           </a:p>
           <a:p>
             <a:pPr lvl="2"/>
             <a:r>
-              <a:rPr lang="en-US" smtClean="0"/>
+              <a:rPr lang="en-US"/>
               <a:t>Third level</a:t>
             </a:r>
           </a:p>
           <a:p>
             <a:pPr lvl="3"/>
             <a:r>
-              <a:rPr lang="en-US" smtClean="0"/>
+              <a:rPr lang="en-US"/>
               <a:t>Fourth level</a:t>
             </a:r>
           </a:p>
           <a:p>
             <a:pPr lvl="4"/>
             <a:r>
-              <a:rPr lang="en-US" smtClean="0"/>
+              <a:rPr lang="en-US"/>
               <a:t>Fifth level</a:t>
             </a:r>
-            <a:endParaRPr lang="en-US"/>
           </a:p>
         </p:txBody>
       </p:sp>
@@ -1353,7 +1356,7 @@
           <a:p>
             <a:fld id="{5BCAD085-E8A6-8845-BD4E-CB4CCA059FC4}" type="datetimeFigureOut">
               <a:rPr lang="en-US" smtClean="0"/>
-              <a:t>1/27/13</a:t>
+              <a:t>5/26/2026</a:t>
             </a:fld>
             <a:endParaRPr lang="en-US"/>
           </a:p>
@@ -1451,10 +1454,9 @@
           </a:lstStyle>
           <a:p>
             <a:r>
-              <a:rPr lang="en-US" smtClean="0"/>
+              <a:rPr lang="en-US"/>
               <a:t>Click to edit Master title style</a:t>
             </a:r>
-            <a:endParaRPr lang="en-US"/>
           </a:p>
         </p:txBody>
       </p:sp>
@@ -1517,7 +1519,7 @@
           <a:p>
             <a:pPr lvl="0"/>
             <a:r>
-              <a:rPr lang="en-US" smtClean="0"/>
+              <a:rPr lang="en-US"/>
               <a:t>Click to edit Master text styles</a:t>
             </a:r>
           </a:p>
@@ -1573,38 +1575,37 @@
           <a:p>
             <a:pPr lvl="0"/>
             <a:r>
-              <a:rPr lang="en-US" smtClean="0"/>
+              <a:rPr lang="en-US"/>
               <a:t>Click to edit Master text styles</a:t>
             </a:r>
           </a:p>
           <a:p>
             <a:pPr lvl="1"/>
             <a:r>
-              <a:rPr lang="en-US" smtClean="0"/>
+              <a:rPr lang="en-US"/>
               <a:t>Second level</a:t>
             </a:r>
           </a:p>
           <a:p>
             <a:pPr lvl="2"/>
             <a:r>
-              <a:rPr lang="en-US" smtClean="0"/>
+              <a:rPr lang="en-US"/>
               <a:t>Third level</a:t>
             </a:r>
           </a:p>
           <a:p>
             <a:pPr lvl="3"/>
             <a:r>
-              <a:rPr lang="en-US" smtClean="0"/>
+              <a:rPr lang="en-US"/>
               <a:t>Fourth level</a:t>
             </a:r>
           </a:p>
           <a:p>
             <a:pPr lvl="4"/>
             <a:r>
-              <a:rPr lang="en-US" smtClean="0"/>
+              <a:rPr lang="en-US"/>
               <a:t>Fifth level</a:t>
             </a:r>
-            <a:endParaRPr lang="en-US"/>
           </a:p>
         </p:txBody>
       </p:sp>
@@ -1667,7 +1668,7 @@
           <a:p>
             <a:pPr lvl="0"/>
             <a:r>
-              <a:rPr lang="en-US" smtClean="0"/>
+              <a:rPr lang="en-US"/>
               <a:t>Click to edit Master text styles</a:t>
             </a:r>
           </a:p>
@@ -1723,38 +1724,37 @@
           <a:p>
             <a:pPr lvl="0"/>
             <a:r>
-              <a:rPr lang="en-US" smtClean="0"/>
+              <a:rPr lang="en-US"/>
               <a:t>Click to edit Master text styles</a:t>
             </a:r>
           </a:p>
           <a:p>
             <a:pPr lvl="1"/>
             <a:r>
-              <a:rPr lang="en-US" smtClean="0"/>
+              <a:rPr lang="en-US"/>
               <a:t>Second level</a:t>
             </a:r>
           </a:p>
           <a:p>
             <a:pPr lvl="2"/>
             <a:r>
-              <a:rPr lang="en-US" smtClean="0"/>
+              <a:rPr lang="en-US"/>
               <a:t>Third level</a:t>
             </a:r>
           </a:p>
           <a:p>
             <a:pPr lvl="3"/>
             <a:r>
-              <a:rPr lang="en-US" smtClean="0"/>
+              <a:rPr lang="en-US"/>
               <a:t>Fourth level</a:t>
             </a:r>
           </a:p>
           <a:p>
             <a:pPr lvl="4"/>
             <a:r>
-              <a:rPr lang="en-US" smtClean="0"/>
+              <a:rPr lang="en-US"/>
               <a:t>Fifth level</a:t>
             </a:r>
-            <a:endParaRPr lang="en-US"/>
           </a:p>
         </p:txBody>
       </p:sp>
@@ -1775,7 +1775,7 @@
           <a:p>
             <a:fld id="{5BCAD085-E8A6-8845-BD4E-CB4CCA059FC4}" type="datetimeFigureOut">
               <a:rPr lang="en-US" smtClean="0"/>
-              <a:t>1/27/13</a:t>
+              <a:t>5/26/2026</a:t>
             </a:fld>
             <a:endParaRPr lang="en-US"/>
           </a:p>
@@ -1869,10 +1869,9 @@
           <a:lstStyle/>
           <a:p>
             <a:r>
-              <a:rPr lang="en-US" smtClean="0"/>
+              <a:rPr lang="en-US"/>
               <a:t>Click to edit Master title style</a:t>
             </a:r>
-            <a:endParaRPr lang="en-US"/>
           </a:p>
         </p:txBody>
       </p:sp>
@@ -1893,7 +1892,7 @@
           <a:p>
             <a:fld id="{5BCAD085-E8A6-8845-BD4E-CB4CCA059FC4}" type="datetimeFigureOut">
               <a:rPr lang="en-US" smtClean="0"/>
-              <a:t>1/27/13</a:t>
+              <a:t>5/26/2026</a:t>
             </a:fld>
             <a:endParaRPr lang="en-US"/>
           </a:p>
@@ -1988,7 +1987,7 @@
           <a:p>
             <a:fld id="{5BCAD085-E8A6-8845-BD4E-CB4CCA059FC4}" type="datetimeFigureOut">
               <a:rPr lang="en-US" smtClean="0"/>
-              <a:t>1/27/13</a:t>
+              <a:t>5/26/2026</a:t>
             </a:fld>
             <a:endParaRPr lang="en-US"/>
           </a:p>
@@ -2091,10 +2090,9 @@
           </a:lstStyle>
           <a:p>
             <a:r>
-              <a:rPr lang="en-US" smtClean="0"/>
+              <a:rPr lang="en-US"/>
               <a:t>Click to edit Master title style</a:t>
             </a:r>
-            <a:endParaRPr lang="en-US"/>
           </a:p>
         </p:txBody>
       </p:sp>
@@ -2148,38 +2146,37 @@
           <a:p>
             <a:pPr lvl="0"/>
             <a:r>
-              <a:rPr lang="en-US" smtClean="0"/>
+              <a:rPr lang="en-US"/>
               <a:t>Click to edit Master text styles</a:t>
             </a:r>
           </a:p>
           <a:p>
             <a:pPr lvl="1"/>
             <a:r>
-              <a:rPr lang="en-US" smtClean="0"/>
+              <a:rPr lang="en-US"/>
               <a:t>Second level</a:t>
             </a:r>
           </a:p>
           <a:p>
             <a:pPr lvl="2"/>
             <a:r>
-              <a:rPr lang="en-US" smtClean="0"/>
+              <a:rPr lang="en-US"/>
               <a:t>Third level</a:t>
             </a:r>
           </a:p>
           <a:p>
             <a:pPr lvl="3"/>
             <a:r>
-              <a:rPr lang="en-US" smtClean="0"/>
+              <a:rPr lang="en-US"/>
               <a:t>Fourth level</a:t>
             </a:r>
           </a:p>
           <a:p>
             <a:pPr lvl="4"/>
             <a:r>
-              <a:rPr lang="en-US" smtClean="0"/>
+              <a:rPr lang="en-US"/>
               <a:t>Fifth level</a:t>
             </a:r>
-            <a:endParaRPr lang="en-US"/>
           </a:p>
         </p:txBody>
       </p:sp>
@@ -2242,7 +2239,7 @@
           <a:p>
             <a:pPr lvl="0"/>
             <a:r>
-              <a:rPr lang="en-US" smtClean="0"/>
+              <a:rPr lang="en-US"/>
               <a:t>Click to edit Master text styles</a:t>
             </a:r>
           </a:p>
@@ -2265,7 +2262,7 @@
           <a:p>
             <a:fld id="{5BCAD085-E8A6-8845-BD4E-CB4CCA059FC4}" type="datetimeFigureOut">
               <a:rPr lang="en-US" smtClean="0"/>
-              <a:t>1/27/13</a:t>
+              <a:t>5/26/2026</a:t>
             </a:fld>
             <a:endParaRPr lang="en-US"/>
           </a:p>
@@ -2368,10 +2365,9 @@
           </a:lstStyle>
           <a:p>
             <a:r>
-              <a:rPr lang="en-US" smtClean="0"/>
+              <a:rPr lang="en-US"/>
               <a:t>Click to edit Master title style</a:t>
             </a:r>
-            <a:endParaRPr lang="en-US"/>
           </a:p>
         </p:txBody>
       </p:sp>
@@ -2495,7 +2491,7 @@
           <a:p>
             <a:pPr lvl="0"/>
             <a:r>
-              <a:rPr lang="en-US" smtClean="0"/>
+              <a:rPr lang="en-US"/>
               <a:t>Click to edit Master text styles</a:t>
             </a:r>
           </a:p>
@@ -2518,7 +2514,7 @@
           <a:p>
             <a:fld id="{5BCAD085-E8A6-8845-BD4E-CB4CCA059FC4}" type="datetimeFigureOut">
               <a:rPr lang="en-US" smtClean="0"/>
-              <a:t>1/27/13</a:t>
+              <a:t>5/26/2026</a:t>
             </a:fld>
             <a:endParaRPr lang="en-US"/>
           </a:p>
@@ -2627,10 +2623,9 @@
           <a:lstStyle/>
           <a:p>
             <a:r>
-              <a:rPr lang="en-US" smtClean="0"/>
+              <a:rPr lang="en-US"/>
               <a:t>Click to edit Master title style</a:t>
             </a:r>
-            <a:endParaRPr lang="en-US"/>
           </a:p>
         </p:txBody>
       </p:sp>
@@ -2661,38 +2656,37 @@
           <a:p>
             <a:pPr lvl="0"/>
             <a:r>
-              <a:rPr lang="en-US" smtClean="0"/>
+              <a:rPr lang="en-US"/>
               <a:t>Click to edit Master text styles</a:t>
             </a:r>
           </a:p>
           <a:p>
             <a:pPr lvl="1"/>
             <a:r>
-              <a:rPr lang="en-US" smtClean="0"/>
+              <a:rPr lang="en-US"/>
               <a:t>Second level</a:t>
             </a:r>
           </a:p>
           <a:p>
             <a:pPr lvl="2"/>
             <a:r>
-              <a:rPr lang="en-US" smtClean="0"/>
+              <a:rPr lang="en-US"/>
               <a:t>Third level</a:t>
             </a:r>
           </a:p>
           <a:p>
             <a:pPr lvl="3"/>
             <a:r>
-              <a:rPr lang="en-US" smtClean="0"/>
+              <a:rPr lang="en-US"/>
               <a:t>Fourth level</a:t>
             </a:r>
           </a:p>
           <a:p>
             <a:pPr lvl="4"/>
             <a:r>
-              <a:rPr lang="en-US" smtClean="0"/>
+              <a:rPr lang="en-US"/>
               <a:t>Fifth level</a:t>
             </a:r>
-            <a:endParaRPr lang="en-US"/>
           </a:p>
         </p:txBody>
       </p:sp>
@@ -2731,7 +2725,7 @@
           <a:p>
             <a:fld id="{5BCAD085-E8A6-8845-BD4E-CB4CCA059FC4}" type="datetimeFigureOut">
               <a:rPr lang="en-US" smtClean="0"/>
-              <a:t>1/27/13</a:t>
+              <a:t>5/26/2026</a:t>
             </a:fld>
             <a:endParaRPr lang="en-US"/>
           </a:p>
@@ -3090,7 +3084,7 @@
 </file>
 
 <file path=ppt/slides/slide1.xml><?xml version="1.0" encoding="utf-8"?>
-<p:sld xmlns:a="http://schemas.openxmlformats.org/drawingml/2006/main" xmlns:p="http://schemas.openxmlformats.org/presentationml/2006/main" xmlns:r="http://schemas.openxmlformats.org/officeDocument/2006/relationships">
+<p:sld xmlns:a="http://schemas.openxmlformats.org/drawingml/2006/main" xmlns:r="http://schemas.openxmlformats.org/officeDocument/2006/relationships" xmlns:p="http://schemas.openxmlformats.org/presentationml/2006/main">
   <p:cSld>
     <p:bg>
       <p:bgPr>
@@ -3106,7 +3100,14 @@
         <p:cNvGrpSpPr/>
         <p:nvPr/>
       </p:nvGrpSpPr>
-      <p:grpSpPr/>
+      <p:grpSpPr>
+        <a:xfrm>
+          <a:off x="0" y="0"/>
+          <a:ext cx="0" cy="0"/>
+          <a:chOff x="0" y="0"/>
+          <a:chExt cx="0" cy="0"/>
+        </a:xfrm>
+      </p:grpSpPr>
       <p:pic>
         <p:nvPicPr>
           <p:cNvPr id="2" name="Picture 1" descr="agentic-coding-infographic-1.png"/>
@@ -3173,7 +3174,7 @@
 </file>
 
 <file path=ppt/slides/slide10.xml><?xml version="1.0" encoding="utf-8"?>
-<p:sld xmlns:a="http://schemas.openxmlformats.org/drawingml/2006/main" xmlns:p="http://schemas.openxmlformats.org/presentationml/2006/main" xmlns:r="http://schemas.openxmlformats.org/officeDocument/2006/relationships">
+<p:sld xmlns:a="http://schemas.openxmlformats.org/drawingml/2006/main" xmlns:r="http://schemas.openxmlformats.org/officeDocument/2006/relationships" xmlns:p="http://schemas.openxmlformats.org/presentationml/2006/main">
   <p:cSld>
     <p:bg>
       <p:bgPr>
@@ -3189,7 +3190,14 @@
         <p:cNvGrpSpPr/>
         <p:nvPr/>
       </p:nvGrpSpPr>
-      <p:grpSpPr/>
+      <p:grpSpPr>
+        <a:xfrm>
+          <a:off x="0" y="0"/>
+          <a:ext cx="0" cy="0"/>
+          <a:chOff x="0" y="0"/>
+          <a:chExt cx="0" cy="0"/>
+        </a:xfrm>
+      </p:grpSpPr>
       <p:pic>
         <p:nvPicPr>
           <p:cNvPr id="2" name="Picture 1" descr="mindmap-hookhub-chapters-20260526.png"/>
@@ -3256,7 +3264,7 @@
 </file>
 
 <file path=ppt/slides/slide11.xml><?xml version="1.0" encoding="utf-8"?>
-<p:sld xmlns:a="http://schemas.openxmlformats.org/drawingml/2006/main" xmlns:p="http://schemas.openxmlformats.org/presentationml/2006/main" xmlns:r="http://schemas.openxmlformats.org/officeDocument/2006/relationships">
+<p:sld xmlns:a="http://schemas.openxmlformats.org/drawingml/2006/main" xmlns:r="http://schemas.openxmlformats.org/officeDocument/2006/relationships" xmlns:p="http://schemas.openxmlformats.org/presentationml/2006/main">
   <p:cSld>
     <p:bg>
       <p:bgPr>
@@ -3272,7 +3280,14 @@
         <p:cNvGrpSpPr/>
         <p:nvPr/>
       </p:nvGrpSpPr>
-      <p:grpSpPr/>
+      <p:grpSpPr>
+        <a:xfrm>
+          <a:off x="0" y="0"/>
+          <a:ext cx="0" cy="0"/>
+          <a:chOff x="0" y="0"/>
+          <a:chExt cx="0" cy="0"/>
+        </a:xfrm>
+      </p:grpSpPr>
       <p:pic>
         <p:nvPicPr>
           <p:cNvPr id="2" name="Picture 1" descr="mindmap-output-styles-20260526.png"/>
@@ -3338,8 +3353,8 @@
 </p:sld>
 </file>
 
-<file path=ppt/slides/slide12.xml><?xml version="1.0" encoding="utf-8"?>
-<p:sld xmlns:a="http://schemas.openxmlformats.org/drawingml/2006/main" xmlns:p="http://schemas.openxmlformats.org/presentationml/2006/main" xmlns:r="http://schemas.openxmlformats.org/officeDocument/2006/relationships">
+<file path=ppt/slides/slide2.xml><?xml version="1.0" encoding="utf-8"?>
+<p:sld xmlns:a="http://schemas.openxmlformats.org/drawingml/2006/main" xmlns:r="http://schemas.openxmlformats.org/officeDocument/2006/relationships" xmlns:p="http://schemas.openxmlformats.org/presentationml/2006/main">
   <p:cSld>
     <p:bg>
       <p:bgPr>
@@ -3355,10 +3370,17 @@
         <p:cNvGrpSpPr/>
         <p:nvPr/>
       </p:nvGrpSpPr>
-      <p:grpSpPr/>
+      <p:grpSpPr>
+        <a:xfrm>
+          <a:off x="0" y="0"/>
+          <a:ext cx="0" cy="0"/>
+          <a:chOff x="0" y="0"/>
+          <a:chExt cx="0" cy="0"/>
+        </a:xfrm>
+      </p:grpSpPr>
       <p:pic>
         <p:nvPicPr>
-          <p:cNvPr id="2" name="Picture 1" descr="banner.png"/>
+          <p:cNvPr id="2" name="Picture 1" descr="agentic-coding-infographic-2.png"/>
           <p:cNvPicPr>
             <a:picLocks noChangeAspect="1"/>
           </p:cNvPicPr>
@@ -3372,8 +3394,8 @@
         </p:blipFill>
         <p:spPr>
           <a:xfrm>
-            <a:off x="975116" y="549360"/>
-            <a:ext cx="10238719" cy="5759279"/>
+            <a:off x="975116" y="571682"/>
+            <a:ext cx="10238719" cy="5714634"/>
           </a:xfrm>
           <a:prstGeom prst="rect">
             <a:avLst/>
@@ -3408,7 +3430,7 @@
                   <a:srgbClr val="888888"/>
                 </a:solidFill>
               </a:rPr>
-              <a:t>12 / 12</a:t>
+              <a:t>2 / 12</a:t>
             </a:r>
           </a:p>
         </p:txBody>
@@ -3421,8 +3443,8 @@
 </p:sld>
 </file>
 
-<file path=ppt/slides/slide2.xml><?xml version="1.0" encoding="utf-8"?>
-<p:sld xmlns:a="http://schemas.openxmlformats.org/drawingml/2006/main" xmlns:p="http://schemas.openxmlformats.org/presentationml/2006/main" xmlns:r="http://schemas.openxmlformats.org/officeDocument/2006/relationships">
+<file path=ppt/slides/slide3.xml><?xml version="1.0" encoding="utf-8"?>
+<p:sld xmlns:a="http://schemas.openxmlformats.org/drawingml/2006/main" xmlns:r="http://schemas.openxmlformats.org/officeDocument/2006/relationships" xmlns:p="http://schemas.openxmlformats.org/presentationml/2006/main">
   <p:cSld>
     <p:bg>
       <p:bgPr>
@@ -3438,10 +3460,17 @@
         <p:cNvGrpSpPr/>
         <p:nvPr/>
       </p:nvGrpSpPr>
-      <p:grpSpPr/>
+      <p:grpSpPr>
+        <a:xfrm>
+          <a:off x="0" y="0"/>
+          <a:ext cx="0" cy="0"/>
+          <a:chOff x="0" y="0"/>
+          <a:chExt cx="0" cy="0"/>
+        </a:xfrm>
+      </p:grpSpPr>
       <p:pic>
         <p:nvPicPr>
-          <p:cNvPr id="2" name="Picture 1" descr="agentic-coding-infographic-2.png"/>
+          <p:cNvPr id="2" name="Picture 1" descr="flowchart-book-summary-20260526-3x.png"/>
           <p:cNvPicPr>
             <a:picLocks noChangeAspect="1"/>
           </p:cNvPicPr>
@@ -3455,8 +3484,8 @@
         </p:blipFill>
         <p:spPr>
           <a:xfrm>
-            <a:off x="975116" y="571682"/>
-            <a:ext cx="10238719" cy="5714634"/>
+            <a:off x="975116" y="2534417"/>
+            <a:ext cx="10238719" cy="1789164"/>
           </a:xfrm>
           <a:prstGeom prst="rect">
             <a:avLst/>
@@ -3491,7 +3520,7 @@
                   <a:srgbClr val="888888"/>
                 </a:solidFill>
               </a:rPr>
-              <a:t>2 / 12</a:t>
+              <a:t>3 / 12</a:t>
             </a:r>
           </a:p>
         </p:txBody>
@@ -3504,8 +3533,8 @@
 </p:sld>
 </file>
 
-<file path=ppt/slides/slide3.xml><?xml version="1.0" encoding="utf-8"?>
-<p:sld xmlns:a="http://schemas.openxmlformats.org/drawingml/2006/main" xmlns:p="http://schemas.openxmlformats.org/presentationml/2006/main" xmlns:r="http://schemas.openxmlformats.org/officeDocument/2006/relationships">
+<file path=ppt/slides/slide4.xml><?xml version="1.0" encoding="utf-8"?>
+<p:sld xmlns:a="http://schemas.openxmlformats.org/drawingml/2006/main" xmlns:r="http://schemas.openxmlformats.org/officeDocument/2006/relationships" xmlns:p="http://schemas.openxmlformats.org/presentationml/2006/main">
   <p:cSld>
     <p:bg>
       <p:bgPr>
@@ -3521,10 +3550,17 @@
         <p:cNvGrpSpPr/>
         <p:nvPr/>
       </p:nvGrpSpPr>
-      <p:grpSpPr/>
+      <p:grpSpPr>
+        <a:xfrm>
+          <a:off x="0" y="0"/>
+          <a:ext cx="0" cy="0"/>
+          <a:chOff x="0" y="0"/>
+          <a:chExt cx="0" cy="0"/>
+        </a:xfrm>
+      </p:grpSpPr>
       <p:pic>
         <p:nvPicPr>
-          <p:cNvPr id="2" name="Picture 1" descr="flowchart-book-summary-20260526-3x.png"/>
+          <p:cNvPr id="2" name="Picture 1" descr="flowchart-book-summary-20260526-5x.png"/>
           <p:cNvPicPr>
             <a:picLocks noChangeAspect="1"/>
           </p:cNvPicPr>
@@ -3574,7 +3610,7 @@
                   <a:srgbClr val="888888"/>
                 </a:solidFill>
               </a:rPr>
-              <a:t>3 / 12</a:t>
+              <a:t>4 / 12</a:t>
             </a:r>
           </a:p>
         </p:txBody>
@@ -3587,8 +3623,8 @@
 </p:sld>
 </file>
 
-<file path=ppt/slides/slide4.xml><?xml version="1.0" encoding="utf-8"?>
-<p:sld xmlns:a="http://schemas.openxmlformats.org/drawingml/2006/main" xmlns:p="http://schemas.openxmlformats.org/presentationml/2006/main" xmlns:r="http://schemas.openxmlformats.org/officeDocument/2006/relationships">
+<file path=ppt/slides/slide5.xml><?xml version="1.0" encoding="utf-8"?>
+<p:sld xmlns:a="http://schemas.openxmlformats.org/drawingml/2006/main" xmlns:r="http://schemas.openxmlformats.org/officeDocument/2006/relationships" xmlns:p="http://schemas.openxmlformats.org/presentationml/2006/main">
   <p:cSld>
     <p:bg>
       <p:bgPr>
@@ -3604,10 +3640,17 @@
         <p:cNvGrpSpPr/>
         <p:nvPr/>
       </p:nvGrpSpPr>
-      <p:grpSpPr/>
+      <p:grpSpPr>
+        <a:xfrm>
+          <a:off x="0" y="0"/>
+          <a:ext cx="0" cy="0"/>
+          <a:chOff x="0" y="0"/>
+          <a:chExt cx="0" cy="0"/>
+        </a:xfrm>
+      </p:grpSpPr>
       <p:pic>
         <p:nvPicPr>
-          <p:cNvPr id="2" name="Picture 1" descr="flowchart-book-summary-20260526-5x.png"/>
+          <p:cNvPr id="2" name="Picture 1" descr="flowchart-book-summary-20260526.png"/>
           <p:cNvPicPr>
             <a:picLocks noChangeAspect="1"/>
           </p:cNvPicPr>
@@ -3657,7 +3700,7 @@
                   <a:srgbClr val="888888"/>
                 </a:solidFill>
               </a:rPr>
-              <a:t>4 / 12</a:t>
+              <a:t>5 / 12</a:t>
             </a:r>
           </a:p>
         </p:txBody>
@@ -3670,8 +3713,8 @@
 </p:sld>
 </file>
 
-<file path=ppt/slides/slide5.xml><?xml version="1.0" encoding="utf-8"?>
-<p:sld xmlns:a="http://schemas.openxmlformats.org/drawingml/2006/main" xmlns:p="http://schemas.openxmlformats.org/presentationml/2006/main" xmlns:r="http://schemas.openxmlformats.org/officeDocument/2006/relationships">
+<file path=ppt/slides/slide6.xml><?xml version="1.0" encoding="utf-8"?>
+<p:sld xmlns:a="http://schemas.openxmlformats.org/drawingml/2006/main" xmlns:r="http://schemas.openxmlformats.org/officeDocument/2006/relationships" xmlns:p="http://schemas.openxmlformats.org/presentationml/2006/main">
   <p:cSld>
     <p:bg>
       <p:bgPr>
@@ -3687,10 +3730,17 @@
         <p:cNvGrpSpPr/>
         <p:nvPr/>
       </p:nvGrpSpPr>
-      <p:grpSpPr/>
+      <p:grpSpPr>
+        <a:xfrm>
+          <a:off x="0" y="0"/>
+          <a:ext cx="0" cy="0"/>
+          <a:chOff x="0" y="0"/>
+          <a:chExt cx="0" cy="0"/>
+        </a:xfrm>
+      </p:grpSpPr>
       <p:pic>
         <p:nvPicPr>
-          <p:cNvPr id="2" name="Picture 1" descr="flowchart-book-summary-20260526.png"/>
+          <p:cNvPr id="2" name="Picture 1" descr="flowchart-claude-extension-20260526.png"/>
           <p:cNvPicPr>
             <a:picLocks noChangeAspect="1"/>
           </p:cNvPicPr>
@@ -3704,8 +3754,8 @@
         </p:blipFill>
         <p:spPr>
           <a:xfrm>
-            <a:off x="975116" y="2534417"/>
-            <a:ext cx="10238719" cy="1789164"/>
+            <a:off x="975116" y="1749672"/>
+            <a:ext cx="10238719" cy="3358655"/>
           </a:xfrm>
           <a:prstGeom prst="rect">
             <a:avLst/>
@@ -3740,7 +3790,7 @@
                   <a:srgbClr val="888888"/>
                 </a:solidFill>
               </a:rPr>
-              <a:t>5 / 12</a:t>
+              <a:t>6 / 12</a:t>
             </a:r>
           </a:p>
         </p:txBody>
@@ -3753,8 +3803,8 @@
 </p:sld>
 </file>
 
-<file path=ppt/slides/slide6.xml><?xml version="1.0" encoding="utf-8"?>
-<p:sld xmlns:a="http://schemas.openxmlformats.org/drawingml/2006/main" xmlns:p="http://schemas.openxmlformats.org/presentationml/2006/main" xmlns:r="http://schemas.openxmlformats.org/officeDocument/2006/relationships">
+<file path=ppt/slides/slide7.xml><?xml version="1.0" encoding="utf-8"?>
+<p:sld xmlns:a="http://schemas.openxmlformats.org/drawingml/2006/main" xmlns:r="http://schemas.openxmlformats.org/officeDocument/2006/relationships" xmlns:p="http://schemas.openxmlformats.org/presentationml/2006/main">
   <p:cSld>
     <p:bg>
       <p:bgPr>
@@ -3770,10 +3820,17 @@
         <p:cNvGrpSpPr/>
         <p:nvPr/>
       </p:nvGrpSpPr>
-      <p:grpSpPr/>
+      <p:grpSpPr>
+        <a:xfrm>
+          <a:off x="0" y="0"/>
+          <a:ext cx="0" cy="0"/>
+          <a:chOff x="0" y="0"/>
+          <a:chExt cx="0" cy="0"/>
+        </a:xfrm>
+      </p:grpSpPr>
       <p:pic>
         <p:nvPicPr>
-          <p:cNvPr id="2" name="Picture 1" descr="flowchart-claude-extension-20260526.png"/>
+          <p:cNvPr id="2" name="Picture 1" descr="flowchart-learning-path-20260526.png"/>
           <p:cNvPicPr>
             <a:picLocks noChangeAspect="1"/>
           </p:cNvPicPr>
@@ -3787,8 +3844,8 @@
         </p:blipFill>
         <p:spPr>
           <a:xfrm>
-            <a:off x="975116" y="1749672"/>
-            <a:ext cx="10238719" cy="3358655"/>
+            <a:off x="5599241" y="548640"/>
+            <a:ext cx="990468" cy="5760720"/>
           </a:xfrm>
           <a:prstGeom prst="rect">
             <a:avLst/>
@@ -3823,7 +3880,7 @@
                   <a:srgbClr val="888888"/>
                 </a:solidFill>
               </a:rPr>
-              <a:t>6 / 12</a:t>
+              <a:t>7 / 12</a:t>
             </a:r>
           </a:p>
         </p:txBody>
@@ -3836,8 +3893,8 @@
 </p:sld>
 </file>
 
-<file path=ppt/slides/slide7.xml><?xml version="1.0" encoding="utf-8"?>
-<p:sld xmlns:a="http://schemas.openxmlformats.org/drawingml/2006/main" xmlns:p="http://schemas.openxmlformats.org/presentationml/2006/main" xmlns:r="http://schemas.openxmlformats.org/officeDocument/2006/relationships">
+<file path=ppt/slides/slide8.xml><?xml version="1.0" encoding="utf-8"?>
+<p:sld xmlns:a="http://schemas.openxmlformats.org/drawingml/2006/main" xmlns:r="http://schemas.openxmlformats.org/officeDocument/2006/relationships" xmlns:p="http://schemas.openxmlformats.org/presentationml/2006/main">
   <p:cSld>
     <p:bg>
       <p:bgPr>
@@ -3853,10 +3910,17 @@
         <p:cNvGrpSpPr/>
         <p:nvPr/>
       </p:nvGrpSpPr>
-      <p:grpSpPr/>
+      <p:grpSpPr>
+        <a:xfrm>
+          <a:off x="0" y="0"/>
+          <a:ext cx="0" cy="0"/>
+          <a:chOff x="0" y="0"/>
+          <a:chExt cx="0" cy="0"/>
+        </a:xfrm>
+      </p:grpSpPr>
       <p:pic>
         <p:nvPicPr>
-          <p:cNvPr id="2" name="Picture 1" descr="flowchart-learning-path-20260526.png"/>
+          <p:cNvPr id="2" name="Picture 1" descr="flowchart-output-styles-20260526.png"/>
           <p:cNvPicPr>
             <a:picLocks noChangeAspect="1"/>
           </p:cNvPicPr>
@@ -3870,8 +3934,8 @@
         </p:blipFill>
         <p:spPr>
           <a:xfrm>
-            <a:off x="5599241" y="548640"/>
-            <a:ext cx="990468" cy="5760720"/>
+            <a:off x="2169443" y="548640"/>
+            <a:ext cx="7850065" cy="5760720"/>
           </a:xfrm>
           <a:prstGeom prst="rect">
             <a:avLst/>
@@ -3906,7 +3970,7 @@
                   <a:srgbClr val="888888"/>
                 </a:solidFill>
               </a:rPr>
-              <a:t>7 / 12</a:t>
+              <a:t>8 / 12</a:t>
             </a:r>
           </a:p>
         </p:txBody>
@@ -3919,8 +3983,8 @@
 </p:sld>
 </file>
 
-<file path=ppt/slides/slide8.xml><?xml version="1.0" encoding="utf-8"?>
-<p:sld xmlns:a="http://schemas.openxmlformats.org/drawingml/2006/main" xmlns:p="http://schemas.openxmlformats.org/presentationml/2006/main" xmlns:r="http://schemas.openxmlformats.org/officeDocument/2006/relationships">
+<file path=ppt/slides/slide9.xml><?xml version="1.0" encoding="utf-8"?>
+<p:sld xmlns:a="http://schemas.openxmlformats.org/drawingml/2006/main" xmlns:r="http://schemas.openxmlformats.org/officeDocument/2006/relationships" xmlns:p="http://schemas.openxmlformats.org/presentationml/2006/main">
   <p:cSld>
     <p:bg>
       <p:bgPr>
@@ -3936,90 +4000,14 @@
         <p:cNvGrpSpPr/>
         <p:nvPr/>
       </p:nvGrpSpPr>
-      <p:grpSpPr/>
-      <p:pic>
-        <p:nvPicPr>
-          <p:cNvPr id="2" name="Picture 1" descr="flowchart-output-styles-20260526.png"/>
-          <p:cNvPicPr>
-            <a:picLocks noChangeAspect="1"/>
-          </p:cNvPicPr>
-          <p:nvPr/>
-        </p:nvPicPr>
-        <p:blipFill>
-          <a:blip r:embed="rId2"/>
-          <a:stretch>
-            <a:fillRect/>
-          </a:stretch>
-        </p:blipFill>
-        <p:spPr>
-          <a:xfrm>
-            <a:off x="2169443" y="548640"/>
-            <a:ext cx="7850065" cy="5760720"/>
-          </a:xfrm>
-          <a:prstGeom prst="rect">
-            <a:avLst/>
-          </a:prstGeom>
-        </p:spPr>
-      </p:pic>
-      <p:sp>
-        <p:nvSpPr>
-          <p:cNvPr id="3" name="TextBox 2"/>
-          <p:cNvSpPr txBox="1"/>
-          <p:nvPr/>
-        </p:nvSpPr>
-        <p:spPr>
-          <a:xfrm>
-            <a:off x="11247120" y="6492240"/>
-            <a:ext cx="731520" cy="274320"/>
-          </a:xfrm>
-          <a:prstGeom prst="rect">
-            <a:avLst/>
-          </a:prstGeom>
-          <a:noFill/>
-        </p:spPr>
-        <p:txBody>
-          <a:bodyPr wrap="none">
-            <a:spAutoFit/>
-          </a:bodyPr>
-          <a:lstStyle/>
-          <a:p>
-            <a:r>
-              <a:rPr sz="900">
-                <a:solidFill>
-                  <a:srgbClr val="888888"/>
-                </a:solidFill>
-              </a:rPr>
-              <a:t>8 / 12</a:t>
-            </a:r>
-          </a:p>
-        </p:txBody>
-      </p:sp>
-    </p:spTree>
-  </p:cSld>
-  <p:clrMapOvr>
-    <a:masterClrMapping/>
-  </p:clrMapOvr>
-</p:sld>
-</file>
-
-<file path=ppt/slides/slide9.xml><?xml version="1.0" encoding="utf-8"?>
-<p:sld xmlns:a="http://schemas.openxmlformats.org/drawingml/2006/main" xmlns:p="http://schemas.openxmlformats.org/presentationml/2006/main" xmlns:r="http://schemas.openxmlformats.org/officeDocument/2006/relationships">
-  <p:cSld>
-    <p:bg>
-      <p:bgPr>
-        <a:solidFill>
-          <a:srgbClr val="1A1A2E"/>
-        </a:solidFill>
-        <a:effectLst/>
-      </p:bgPr>
-    </p:bg>
-    <p:spTree>
-      <p:nvGrpSpPr>
-        <p:cNvPr id="1" name=""/>
-        <p:cNvGrpSpPr/>
-        <p:nvPr/>
-      </p:nvGrpSpPr>
-      <p:grpSpPr/>
+      <p:grpSpPr>
+        <a:xfrm>
+          <a:off x="0" y="0"/>
+          <a:ext cx="0" cy="0"/>
+          <a:chOff x="0" y="0"/>
+          <a:chExt cx="0" cy="0"/>
+        </a:xfrm>
+      </p:grpSpPr>
       <p:pic>
         <p:nvPicPr>
           <p:cNvPr id="2" name="Picture 1" descr="mindmap-book-summary-20260526.png"/>

</xml_diff>